<commit_message>
Refresh stable electrical manual downloads and D12 viewer with specified RS 130-1086 lamps
</commit_message>
<xml_diff>
--- a/heater/electrical/Heating_Rate_Controller_D12_Reviewed_Styled.pptx
+++ b/heater/electrical/Heating_Rate_Controller_D12_Reviewed_Styled.pptx
@@ -11370,7 +11370,7 @@
                 </a:solidFill>
                 <a:latin typeface="Aptos"/>
               </a:rPr>
-              <a:t>Validate SSR heat sink, Weidmüller SSR+LED total current &lt;=100 mA, protective earth and emergency disconnection.</a:t>
+              <a:t>Validate SSR heat sink, W1/W2 100 mA output (SSR+LED 35 mA max calculated), PE and emergency disconnection.</a:t>
             </a:r>
           </a:p>
         </p:txBody>
@@ -11522,8 +11522,9 @@
                   <a:srgbClr val="A35B1B"/>
                 </a:solidFill>
                 <a:latin typeface="Aptos"/>
-              </a:rPr>
-              <a:t>HL1/HL2 activity indicators: 24 V DC with integral current limitation; manufacturer / current TBD.</a:t>
+                <a:hlinkClick r:id="rId13"/>
+              </a:rPr>
+              <a:t>HL1/HL2 specified: RS PRO 130-1086 yellow LED, 24 V DC, max 20 mA, IP67; 14 mm mounting hole.</a:t>
             </a:r>
           </a:p>
         </p:txBody>
@@ -22404,7 +22405,7 @@
                 </a:solidFill>
                 <a:latin typeface="Aptos"/>
               </a:rPr>
-              <a:t>LED is on the 24 V CONTROL circuit, not across the external 0-60 V heater. Actual indicator type/current is TBD.</a:t>
+              <a:t>LED is on the 24 V CONTROL circuit, not the external heater: HL1/HL2 = RS 130-1086, yellow, 24 V DC, 20 mA max.</a:t>
             </a:r>
           </a:p>
         </p:txBody>
@@ -23276,8 +23277,9 @@
                   <a:srgbClr val="607084"/>
                 </a:solidFill>
                 <a:latin typeface="Aptos"/>
-              </a:rPr>
-              <a:t>Selected part &amp; current TBD</a:t>
+                <a:hlinkClick r:id="rId5"/>
+              </a:rPr>
+              <a:t>RS 130-1086  •  20 mA max</a:t>
             </a:r>
           </a:p>
         </p:txBody>
@@ -25671,7 +25673,7 @@
                 </a:solidFill>
                 <a:latin typeface="Aptos"/>
               </a:rPr>
-              <a:t>Electrical check: SSR input current + lamp input current must stay below the 100 mA Weidmüller DC1 limit; use a rated 24 V indicator.</a:t>
+              <a:t>Datasheet budget: SSR max 15 mA + HL yellow LED max 20 mA = 35 mA per channel; W1/W2 DC1 output max 100 mA. Verify live circuit.</a:t>
             </a:r>
           </a:p>
         </p:txBody>
@@ -26286,7 +26288,7 @@
                 </a:solidFill>
                 <a:latin typeface="Aptos"/>
               </a:rPr>
-              <a:t>LED is on the 24 V CONTROL circuit, not across the external 0-60 V heater. Actual indicator type/current is TBD.</a:t>
+              <a:t>LED is on the 24 V CONTROL circuit, not the external heater: HL1/HL2 = RS 130-1086, yellow, 24 V DC, 20 mA max.</a:t>
             </a:r>
           </a:p>
         </p:txBody>
@@ -27158,8 +27160,9 @@
                   <a:srgbClr val="607084"/>
                 </a:solidFill>
                 <a:latin typeface="Aptos"/>
-              </a:rPr>
-              <a:t>Selected part &amp; current TBD</a:t>
+                <a:hlinkClick r:id="rId5"/>
+              </a:rPr>
+              <a:t>RS 130-1086  •  20 mA max</a:t>
             </a:r>
           </a:p>
         </p:txBody>
@@ -29553,7 +29556,7 @@
                 </a:solidFill>
                 <a:latin typeface="Aptos"/>
               </a:rPr>
-              <a:t>Electrical check: SSR input current + lamp input current must stay below the 100 mA Weidmüller DC1 limit; use a rated 24 V indicator.</a:t>
+              <a:t>Datasheet budget: SSR max 15 mA + HL yellow LED max 20 mA = 35 mA per channel; W1/W2 DC1 output max 100 mA. Verify live circuit.</a:t>
             </a:r>
           </a:p>
         </p:txBody>

</xml_diff>

<commit_message>
Publish D12 selector contact correction in editable PPT, PDF and complete schematic viewer
</commit_message>
<xml_diff>
--- a/heater/electrical/Heating_Rate_Controller_D12_Reviewed_Styled.pptx
+++ b/heater/electrical/Heating_Rate_Controller_D12_Reviewed_Styled.pptx
@@ -4391,7 +4391,7 @@
         <p:spPr>
           <a:xfrm>
             <a:off x="7744968" y="4677156"/>
-            <a:ext cx="1078992" cy="219456"/>
+            <a:ext cx="1225296" cy="219456"/>
           </a:xfrm>
           <a:prstGeom prst="rect">
             <a:avLst/>
@@ -4412,7 +4412,7 @@
                 </a:solidFill>
                 <a:latin typeface="Aptos"/>
               </a:rPr>
-              <a:t>S1  SELECTOR</a:t>
+              <a:t>S1-A  SELECTOR</a:t>
             </a:r>
           </a:p>
         </p:txBody>
@@ -4672,7 +4672,7 @@
                 </a:solidFill>
                 <a:latin typeface="Aptos"/>
               </a:rPr>
-              <a:t>NO contact 13–14</a:t>
+              <a:t>A  ·  NO 13–14</a:t>
             </a:r>
           </a:p>
         </p:txBody>
@@ -4769,7 +4769,7 @@
         <p:spPr>
           <a:xfrm>
             <a:off x="7744968" y="6743700"/>
-            <a:ext cx="1078992" cy="219456"/>
+            <a:ext cx="1225296" cy="219456"/>
           </a:xfrm>
           <a:prstGeom prst="rect">
             <a:avLst/>
@@ -4790,7 +4790,7 @@
                 </a:solidFill>
                 <a:latin typeface="Aptos"/>
               </a:rPr>
-              <a:t>S2  SELECTOR</a:t>
+              <a:t>S2-A  SELECTOR</a:t>
             </a:r>
           </a:p>
         </p:txBody>
@@ -5050,7 +5050,7 @@
                 </a:solidFill>
                 <a:latin typeface="Aptos"/>
               </a:rPr>
-              <a:t>NO contact 13–14</a:t>
+              <a:t>A  ·  NO 13–14</a:t>
             </a:r>
           </a:p>
         </p:txBody>
@@ -11134,7 +11134,7 @@
                 </a:solidFill>
                 <a:latin typeface="Aptos"/>
               </a:rPr>
-              <a:t>Confirm physical X1–X4 blocks, Schneider second NO contacts, J1 outlet tabs and actual Finder 62.31 sockets.</a:t>
+              <a:t>Confirm X1–X4 blocks, Schneider S1/S2 B-contact terminal stamps (23/24* IEC intended), J1 tabs and Finder 62.31 sockets.</a:t>
             </a:r>
           </a:p>
         </p:txBody>
@@ -11910,29 +11910,37 @@
         </p:nvSpPr>
         <p:spPr>
           <a:xfrm>
-            <a:off x="667512" y="9537192"/>
-            <a:ext cx="13560552" cy="182880"/>
-          </a:xfrm>
-          <a:prstGeom prst="rect">
-            <a:avLst/>
-          </a:prstGeom>
-          <a:noFill/>
-        </p:spPr>
-        <p:txBody>
-          <a:bodyPr wrap="none" lIns="9144" tIns="0" rIns="9144" bIns="0" anchor="ctr">
-            <a:spAutoFit/>
-          </a:bodyPr>
-          <a:lstStyle/>
-          <a:p>
-            <a:pPr algn="l"/>
-            <a:r>
-              <a:rPr sz="835" b="0">
-                <a:solidFill>
-                  <a:srgbClr val="607084"/>
-                </a:solidFill>
-                <a:latin typeface="Aptos"/>
-              </a:rPr>
-              <a:t>S1/S2 second contact numbering and distribution terminal hardware not yet confirmed.</a:t>
+            <a:off x="667512" y="8065008"/>
+            <a:ext cx="13395960" cy="475488"/>
+          </a:xfrm>
+          <a:prstGeom prst="rect">
+            <a:avLst/>
+          </a:prstGeom>
+          <a:noFill/>
+        </p:spPr>
+        <p:txBody>
+          <a:bodyPr wrap="square" lIns="9144" tIns="0" rIns="9144" bIns="0" anchor="ctr">
+            <a:spAutoFit/>
+          </a:bodyPr>
+          <a:lstStyle/>
+          <a:p>
+            <a:r>
+              <a:rPr sz="1030">
+                <a:solidFill>
+                  <a:srgbClr val="3F5A6F"/>
+                </a:solidFill>
+              </a:rPr>
+              <a:t>Selector terminal references:  A = 13–14 (AC)   |   B = 23–24* (gated +24 V).</a:t>
+            </a:r>
+          </a:p>
+          <a:p>
+            <a:r>
+              <a:rPr sz="1030">
+                <a:solidFill>
+                  <a:srgbClr val="3F5A6F"/>
+                </a:solidFill>
+              </a:rPr>
+              <a:t>* IEC design labels only. Confirm stamps on the actual XB5AD23 contact-block assembly before wiring; X2–X4 distribution hardware remains TBD.</a:t>
             </a:r>
           </a:p>
         </p:txBody>
@@ -13340,8 +13348,9 @@
           <a:bodyPr rtlCol="0" anchor="ctr"/>
           <a:lstStyle/>
           <a:p>
-            <a:pPr algn="ctr"/>
-            <a:endParaRPr/>
+            <a:r>
+              <a:t>23</a:t>
+            </a:r>
           </a:p>
         </p:txBody>
       </p:sp>
@@ -13375,7 +13384,7 @@
                 </a:solidFill>
                 <a:latin typeface="Aptos"/>
               </a:rPr>
-              <a:t>13</a:t>
+              <a:t>23</a:t>
             </a:r>
           </a:p>
         </p:txBody>
@@ -13421,8 +13430,9 @@
           <a:bodyPr rtlCol="0" anchor="ctr"/>
           <a:lstStyle/>
           <a:p>
-            <a:pPr algn="ctr"/>
-            <a:endParaRPr/>
+            <a:r>
+              <a:t>24</a:t>
+            </a:r>
           </a:p>
         </p:txBody>
       </p:sp>
@@ -13456,7 +13466,7 @@
                 </a:solidFill>
                 <a:latin typeface="Aptos"/>
               </a:rPr>
-              <a:t>14</a:t>
+              <a:t>24</a:t>
             </a:r>
           </a:p>
         </p:txBody>
@@ -13585,8 +13595,8 @@
         </p:nvCxnSpPr>
         <p:spPr>
           <a:xfrm>
-            <a:off x="6629400" y="3145536"/>
-            <a:ext cx="987552" cy="0"/>
+            <a:off x="7187184" y="3145536"/>
+            <a:ext cx="429768" cy="0"/>
           </a:xfrm>
           <a:prstGeom prst="line">
             <a:avLst/>
@@ -13621,7 +13631,7 @@
         <p:spPr>
           <a:xfrm>
             <a:off x="7891272" y="3145536"/>
-            <a:ext cx="987552" cy="0"/>
+            <a:ext cx="429768" cy="0"/>
           </a:xfrm>
           <a:prstGeom prst="line">
             <a:avLst/>
@@ -14128,8 +14138,9 @@
           <a:bodyPr rtlCol="0" anchor="ctr"/>
           <a:lstStyle/>
           <a:p>
-            <a:pPr algn="ctr"/>
-            <a:endParaRPr/>
+            <a:r>
+              <a:t>23</a:t>
+            </a:r>
           </a:p>
         </p:txBody>
       </p:sp>
@@ -14163,7 +14174,7 @@
                 </a:solidFill>
                 <a:latin typeface="Aptos"/>
               </a:rPr>
-              <a:t>13</a:t>
+              <a:t>23</a:t>
             </a:r>
           </a:p>
         </p:txBody>
@@ -14209,8 +14220,9 @@
           <a:bodyPr rtlCol="0" anchor="ctr"/>
           <a:lstStyle/>
           <a:p>
-            <a:pPr algn="ctr"/>
-            <a:endParaRPr/>
+            <a:r>
+              <a:t>24</a:t>
+            </a:r>
           </a:p>
         </p:txBody>
       </p:sp>
@@ -14244,7 +14256,7 @@
                 </a:solidFill>
                 <a:latin typeface="Aptos"/>
               </a:rPr>
-              <a:t>14</a:t>
+              <a:t>24</a:t>
             </a:r>
           </a:p>
         </p:txBody>
@@ -14373,8 +14385,8 @@
         </p:nvCxnSpPr>
         <p:spPr>
           <a:xfrm>
-            <a:off x="6629400" y="5806440"/>
-            <a:ext cx="987552" cy="0"/>
+            <a:off x="7187184" y="5806440"/>
+            <a:ext cx="429768" cy="0"/>
           </a:xfrm>
           <a:prstGeom prst="line">
             <a:avLst/>
@@ -14409,7 +14421,7 @@
         <p:spPr>
           <a:xfrm>
             <a:off x="7891272" y="5806440"/>
-            <a:ext cx="987552" cy="0"/>
+            <a:ext cx="429768" cy="0"/>
           </a:xfrm>
           <a:prstGeom prst="line">
             <a:avLst/>
@@ -15022,6 +15034,74 @@
                 <a:latin typeface="Aptos"/>
               </a:rPr>
               <a:t>0 V return</a:t>
+            </a:r>
+          </a:p>
+        </p:txBody>
+      </p:sp>
+      <p:sp>
+        <p:nvSpPr>
+          <p:cNvPr id="90" name="CONTACT ID S1-B 23-24"/>
+          <p:cNvSpPr txBox="1"/>
+          <p:nvPr/>
+        </p:nvSpPr>
+        <p:spPr>
+          <a:xfrm>
+            <a:off x="6848856" y="3415284"/>
+            <a:ext cx="1810512" cy="173736"/>
+          </a:xfrm>
+          <a:prstGeom prst="rect">
+            <a:avLst/>
+          </a:prstGeom>
+          <a:noFill/>
+        </p:spPr>
+        <p:txBody>
+          <a:bodyPr wrap="none" lIns="0" rIns="0" tIns="0" bIns="0">
+            <a:spAutoFit/>
+          </a:bodyPr>
+          <a:lstStyle/>
+          <a:p>
+            <a:pPr algn="ctr"/>
+            <a:r>
+              <a:rPr sz="850" b="1">
+                <a:solidFill>
+                  <a:srgbClr val="365E75"/>
+                </a:solidFill>
+              </a:rPr>
+              <a:t>B  ·  NO 23–24*</a:t>
+            </a:r>
+          </a:p>
+        </p:txBody>
+      </p:sp>
+      <p:sp>
+        <p:nvSpPr>
+          <p:cNvPr id="91" name="CONTACT ID S2-B 23-24"/>
+          <p:cNvSpPr txBox="1"/>
+          <p:nvPr/>
+        </p:nvSpPr>
+        <p:spPr>
+          <a:xfrm>
+            <a:off x="6848856" y="6076188"/>
+            <a:ext cx="1810512" cy="173736"/>
+          </a:xfrm>
+          <a:prstGeom prst="rect">
+            <a:avLst/>
+          </a:prstGeom>
+          <a:noFill/>
+        </p:spPr>
+        <p:txBody>
+          <a:bodyPr wrap="none" lIns="0" rIns="0" tIns="0" bIns="0">
+            <a:spAutoFit/>
+          </a:bodyPr>
+          <a:lstStyle/>
+          <a:p>
+            <a:pPr algn="ctr"/>
+            <a:r>
+              <a:rPr sz="850" b="1">
+                <a:solidFill>
+                  <a:srgbClr val="365E75"/>
+                </a:solidFill>
+              </a:rPr>
+              <a:t>B  ·  NO 23–24*</a:t>
             </a:r>
           </a:p>
         </p:txBody>
@@ -39487,7 +39567,7 @@
                 </a:solidFill>
                 <a:latin typeface="Aptos"/>
               </a:rPr>
-              <a:t>X2:+24 → S1-B NO</a:t>
+              <a:t>X2:+24 → S1-B:23/24*</a:t>
             </a:r>
           </a:p>
         </p:txBody>
@@ -39721,7 +39801,7 @@
                 </a:solidFill>
                 <a:latin typeface="Aptos"/>
               </a:rPr>
-              <a:t>X2:+24 → S2-B NO</a:t>
+              <a:t>X2:+24 → S2-B:23/24*</a:t>
             </a:r>
           </a:p>
         </p:txBody>
@@ -40060,7 +40140,7 @@
                 </a:solidFill>
                 <a:latin typeface="Aptos"/>
               </a:rPr>
-              <a:t>Required before wiring: J1 output tabs; enclosure PE point; X1–X4 actual stock numbers and jumpers; mains and 24 V fuse values.</a:t>
+              <a:t>Before wiring: confirm selector B contact-block stamps (*23/24 IEC proposed), J1 tabs, PE, X1–X4 blocks/jumpers and mains/24 V fuses.</a:t>
             </a:r>
           </a:p>
         </p:txBody>

</xml_diff>